<commit_message>
Fix layout bugs and add quality verification for the tire-recycling deck
LibreOffice headless conversion is broken in this container (fails even
on plain .txt), so visual rendering isn't available. Added audit_ppt.py
to catch off-canvas shapes and textbox overlap programmatically, which
found and fixed: overlapping images on the benefits slide, an orphaned
icon overlapping a card title, a chart bleeding past the footer, and a
badge label overlapping a slide title's bounding box.

Also added quality_review.py, which runs the cli-anything-wps skill's
own 5-dimension review rubric (quality_checks.py) against the deck:
scores 78/100 overall, passing the 70-point visual threshold.

Co-Authored-By: Claude Opus 4.8 <noreply@anthropic.com>
Claude-Session: https://claude.ai/code/session_01AK3oEnxqc2RnmRuD3aGYUv
</commit_message>
<xml_diff>
--- a/presentation/废旧轮胎的回收与资源化利用.pptx
+++ b/presentation/废旧轮胎的回收与资源化利用.pptx
@@ -3207,8 +3207,8 @@
         </p:nvSpPr>
         <p:spPr>
           <a:xfrm>
-            <a:off x="9144000" y="3810000"/>
-            <a:ext cx="4572000" cy="4572000"/>
+            <a:off x="8890000" y="3556000"/>
+            <a:ext cx="4064000" cy="4064000"/>
           </a:xfrm>
           <a:prstGeom prst="ellipse">
             <a:avLst/>
@@ -3251,8 +3251,8 @@
         </p:nvSpPr>
         <p:spPr>
           <a:xfrm>
-            <a:off x="9652000" y="4318000"/>
-            <a:ext cx="3556000" cy="3556000"/>
+            <a:off x="9334500" y="4000500"/>
+            <a:ext cx="3175000" cy="3175000"/>
           </a:xfrm>
           <a:prstGeom prst="ellipse">
             <a:avLst/>
@@ -5291,8 +5291,8 @@
         </p:nvSpPr>
         <p:spPr>
           <a:xfrm>
-            <a:off x="8890000" y="431800"/>
-            <a:ext cx="2667000" cy="508000"/>
+            <a:off x="10160000" y="457200"/>
+            <a:ext cx="1905000" cy="406400"/>
           </a:xfrm>
           <a:prstGeom prst="roundRect">
             <a:avLst/>
@@ -5329,7 +5329,7 @@
               </a:lnSpc>
             </a:pPr>
             <a:r>
-              <a:rPr sz="1600" b="1">
+              <a:rPr sz="1350" b="1">
                 <a:solidFill>
                   <a:srgbClr val="FFFFFF"/>
                 </a:solidFill>
@@ -5721,8 +5721,8 @@
         </p:nvSpPr>
         <p:spPr>
           <a:xfrm>
-            <a:off x="635000" y="5969000"/>
-            <a:ext cx="5461000" cy="635000"/>
+            <a:off x="635000" y="5892800"/>
+            <a:ext cx="5461000" cy="508000"/>
           </a:xfrm>
           <a:prstGeom prst="rect">
             <a:avLst/>
@@ -5765,8 +5765,8 @@
         </p:nvSpPr>
         <p:spPr>
           <a:xfrm>
-            <a:off x="635000" y="5969000"/>
-            <a:ext cx="101600" cy="635000"/>
+            <a:off x="635000" y="5892800"/>
+            <a:ext cx="101600" cy="508000"/>
           </a:xfrm>
           <a:prstGeom prst="rect">
             <a:avLst/>
@@ -5809,8 +5809,8 @@
         </p:nvSpPr>
         <p:spPr>
           <a:xfrm>
-            <a:off x="889000" y="5969000"/>
-            <a:ext cx="5207000" cy="635000"/>
+            <a:off x="889000" y="5892800"/>
+            <a:ext cx="5207000" cy="508000"/>
           </a:xfrm>
           <a:prstGeom prst="rect">
             <a:avLst/>
@@ -5825,11 +5825,11 @@
           <a:p>
             <a:pPr algn="l">
               <a:lnSpc>
-                <a:spcPct val="115000"/>
-              </a:lnSpc>
-            </a:pPr>
-            <a:r>
-              <a:rPr sz="1400" b="1">
+                <a:spcPct val="110000"/>
+              </a:lnSpc>
+            </a:pPr>
+            <a:r>
+              <a:rPr sz="1350" b="1">
                 <a:solidFill>
                   <a:srgbClr val="1A3C8B"/>
                 </a:solidFill>
@@ -6075,8 +6075,8 @@
         </p:nvSpPr>
         <p:spPr>
           <a:xfrm>
-            <a:off x="8890000" y="431800"/>
-            <a:ext cx="2667000" cy="508000"/>
+            <a:off x="10160000" y="457200"/>
+            <a:ext cx="1905000" cy="406400"/>
           </a:xfrm>
           <a:prstGeom prst="roundRect">
             <a:avLst/>
@@ -6113,7 +6113,7 @@
               </a:lnSpc>
             </a:pPr>
             <a:r>
-              <a:rPr sz="1600" b="1">
+              <a:rPr sz="1350" b="1">
                 <a:solidFill>
                   <a:srgbClr val="FFFFFF"/>
                 </a:solidFill>
@@ -6529,7 +6529,7 @@
         </p:nvSpPr>
         <p:spPr>
           <a:xfrm>
-            <a:off x="6350000" y="5969000"/>
+            <a:off x="6350000" y="4605659"/>
             <a:ext cx="5461000" cy="304800"/>
           </a:xfrm>
           <a:prstGeom prst="rect">
@@ -6569,8 +6569,8 @@
         </p:nvSpPr>
         <p:spPr>
           <a:xfrm>
-            <a:off x="635000" y="5969000"/>
-            <a:ext cx="5461000" cy="635000"/>
+            <a:off x="635000" y="5892800"/>
+            <a:ext cx="5461000" cy="508000"/>
           </a:xfrm>
           <a:prstGeom prst="rect">
             <a:avLst/>
@@ -6613,8 +6613,8 @@
         </p:nvSpPr>
         <p:spPr>
           <a:xfrm>
-            <a:off x="635000" y="5969000"/>
-            <a:ext cx="101600" cy="635000"/>
+            <a:off x="635000" y="5892800"/>
+            <a:ext cx="101600" cy="508000"/>
           </a:xfrm>
           <a:prstGeom prst="rect">
             <a:avLst/>
@@ -6657,8 +6657,8 @@
         </p:nvSpPr>
         <p:spPr>
           <a:xfrm>
-            <a:off x="889000" y="5969000"/>
-            <a:ext cx="5207000" cy="635000"/>
+            <a:off x="889000" y="5892800"/>
+            <a:ext cx="5207000" cy="508000"/>
           </a:xfrm>
           <a:prstGeom prst="rect">
             <a:avLst/>
@@ -6673,11 +6673,11 @@
           <a:p>
             <a:pPr algn="l">
               <a:lnSpc>
-                <a:spcPct val="115000"/>
-              </a:lnSpc>
-            </a:pPr>
-            <a:r>
-              <a:rPr sz="1400" b="1">
+                <a:spcPct val="110000"/>
+              </a:lnSpc>
+            </a:pPr>
+            <a:r>
+              <a:rPr sz="1350" b="1">
                 <a:solidFill>
                   <a:srgbClr val="1A3C8B"/>
                 </a:solidFill>
@@ -6923,8 +6923,8 @@
         </p:nvSpPr>
         <p:spPr>
           <a:xfrm>
-            <a:off x="8890000" y="431800"/>
-            <a:ext cx="2667000" cy="508000"/>
+            <a:off x="10160000" y="457200"/>
+            <a:ext cx="1905000" cy="406400"/>
           </a:xfrm>
           <a:prstGeom prst="roundRect">
             <a:avLst/>
@@ -6961,7 +6961,7 @@
               </a:lnSpc>
             </a:pPr>
             <a:r>
-              <a:rPr sz="1600" b="1">
+              <a:rPr sz="1350" b="1">
                 <a:solidFill>
                   <a:srgbClr val="FFFFFF"/>
                 </a:solidFill>
@@ -7377,7 +7377,7 @@
         </p:nvSpPr>
         <p:spPr>
           <a:xfrm>
-            <a:off x="6350000" y="5969000"/>
+            <a:off x="6350000" y="3618745"/>
             <a:ext cx="5461000" cy="304800"/>
           </a:xfrm>
           <a:prstGeom prst="rect">
@@ -7417,8 +7417,8 @@
         </p:nvSpPr>
         <p:spPr>
           <a:xfrm>
-            <a:off x="635000" y="5969000"/>
-            <a:ext cx="5461000" cy="635000"/>
+            <a:off x="635000" y="5892800"/>
+            <a:ext cx="5461000" cy="508000"/>
           </a:xfrm>
           <a:prstGeom prst="rect">
             <a:avLst/>
@@ -7461,8 +7461,8 @@
         </p:nvSpPr>
         <p:spPr>
           <a:xfrm>
-            <a:off x="635000" y="5969000"/>
-            <a:ext cx="101600" cy="635000"/>
+            <a:off x="635000" y="5892800"/>
+            <a:ext cx="101600" cy="508000"/>
           </a:xfrm>
           <a:prstGeom prst="rect">
             <a:avLst/>
@@ -7505,8 +7505,8 @@
         </p:nvSpPr>
         <p:spPr>
           <a:xfrm>
-            <a:off x="889000" y="5969000"/>
-            <a:ext cx="5207000" cy="635000"/>
+            <a:off x="889000" y="5892800"/>
+            <a:ext cx="5207000" cy="508000"/>
           </a:xfrm>
           <a:prstGeom prst="rect">
             <a:avLst/>
@@ -7521,11 +7521,11 @@
           <a:p>
             <a:pPr algn="l">
               <a:lnSpc>
-                <a:spcPct val="115000"/>
-              </a:lnSpc>
-            </a:pPr>
-            <a:r>
-              <a:rPr sz="1400" b="1">
+                <a:spcPct val="110000"/>
+              </a:lnSpc>
+            </a:pPr>
+            <a:r>
+              <a:rPr sz="1350" b="1">
                 <a:solidFill>
                   <a:srgbClr val="1A3C8B"/>
                 </a:solidFill>
@@ -7771,8 +7771,8 @@
         </p:nvSpPr>
         <p:spPr>
           <a:xfrm>
-            <a:off x="8890000" y="431800"/>
-            <a:ext cx="2667000" cy="508000"/>
+            <a:off x="10160000" y="457200"/>
+            <a:ext cx="1905000" cy="406400"/>
           </a:xfrm>
           <a:prstGeom prst="roundRect">
             <a:avLst/>
@@ -7809,7 +7809,7 @@
               </a:lnSpc>
             </a:pPr>
             <a:r>
-              <a:rPr sz="1600" b="1">
+              <a:rPr sz="1350" b="1">
                 <a:solidFill>
                   <a:srgbClr val="FFFFFF"/>
                 </a:solidFill>
@@ -8201,8 +8201,8 @@
         </p:nvSpPr>
         <p:spPr>
           <a:xfrm>
-            <a:off x="635000" y="5969000"/>
-            <a:ext cx="5461000" cy="635000"/>
+            <a:off x="635000" y="5892800"/>
+            <a:ext cx="5461000" cy="508000"/>
           </a:xfrm>
           <a:prstGeom prst="rect">
             <a:avLst/>
@@ -8245,8 +8245,8 @@
         </p:nvSpPr>
         <p:spPr>
           <a:xfrm>
-            <a:off x="635000" y="5969000"/>
-            <a:ext cx="101600" cy="635000"/>
+            <a:off x="635000" y="5892800"/>
+            <a:ext cx="101600" cy="508000"/>
           </a:xfrm>
           <a:prstGeom prst="rect">
             <a:avLst/>
@@ -8289,8 +8289,8 @@
         </p:nvSpPr>
         <p:spPr>
           <a:xfrm>
-            <a:off x="889000" y="5969000"/>
-            <a:ext cx="5207000" cy="635000"/>
+            <a:off x="889000" y="5892800"/>
+            <a:ext cx="5207000" cy="508000"/>
           </a:xfrm>
           <a:prstGeom prst="rect">
             <a:avLst/>
@@ -8305,11 +8305,11 @@
           <a:p>
             <a:pPr algn="l">
               <a:lnSpc>
-                <a:spcPct val="115000"/>
-              </a:lnSpc>
-            </a:pPr>
-            <a:r>
-              <a:rPr sz="1400" b="1">
+                <a:spcPct val="110000"/>
+              </a:lnSpc>
+            </a:pPr>
+            <a:r>
+              <a:rPr sz="1350" b="1">
                 <a:solidFill>
                   <a:srgbClr val="1A3C8B"/>
                 </a:solidFill>
@@ -11385,8 +11385,8 @@
         </p:nvSpPr>
         <p:spPr>
           <a:xfrm>
-            <a:off x="635000" y="5461000"/>
-            <a:ext cx="5461000" cy="1143000"/>
+            <a:off x="635000" y="5397500"/>
+            <a:ext cx="5461000" cy="889000"/>
           </a:xfrm>
           <a:prstGeom prst="rect">
             <a:avLst/>
@@ -13220,8 +13220,8 @@
         </p:blipFill>
         <p:spPr>
           <a:xfrm>
-            <a:off x="635000" y="1397000"/>
-            <a:ext cx="5969000" cy="3375276"/>
+            <a:off x="635000" y="1422400"/>
+            <a:ext cx="3937000" cy="2226246"/>
           </a:xfrm>
           <a:prstGeom prst="rect">
             <a:avLst/>
@@ -13244,8 +13244,8 @@
         </p:blipFill>
         <p:spPr>
           <a:xfrm>
-            <a:off x="635000" y="4064000"/>
-            <a:ext cx="5969000" cy="3596003"/>
+            <a:off x="635000" y="3839146"/>
+            <a:ext cx="3937000" cy="2371832"/>
           </a:xfrm>
           <a:prstGeom prst="rect">
             <a:avLst/>
@@ -13260,8 +13260,8 @@
         </p:nvSpPr>
         <p:spPr>
           <a:xfrm>
-            <a:off x="6921500" y="1397000"/>
-            <a:ext cx="4826000" cy="1549400"/>
+            <a:off x="5842000" y="1397000"/>
+            <a:ext cx="4699000" cy="1549400"/>
           </a:xfrm>
           <a:prstGeom prst="rect">
             <a:avLst/>
@@ -13311,7 +13311,7 @@
         </p:nvSpPr>
         <p:spPr>
           <a:xfrm>
-            <a:off x="6921500" y="1397000"/>
+            <a:off x="5842000" y="1397000"/>
             <a:ext cx="127000" cy="1549400"/>
           </a:xfrm>
           <a:prstGeom prst="rect">
@@ -13355,8 +13355,8 @@
         </p:nvSpPr>
         <p:spPr>
           <a:xfrm>
-            <a:off x="7264400" y="1549400"/>
-            <a:ext cx="4318000" cy="381000"/>
+            <a:off x="6184900" y="1549400"/>
+            <a:ext cx="4254500" cy="381000"/>
           </a:xfrm>
           <a:prstGeom prst="rect">
             <a:avLst/>
@@ -13395,8 +13395,8 @@
         </p:nvSpPr>
         <p:spPr>
           <a:xfrm>
-            <a:off x="7264400" y="1981200"/>
-            <a:ext cx="4381500" cy="914400"/>
+            <a:off x="6184900" y="1981200"/>
+            <a:ext cx="4254500" cy="914400"/>
           </a:xfrm>
           <a:prstGeom prst="rect">
             <a:avLst/>
@@ -13469,8 +13469,8 @@
         </p:nvSpPr>
         <p:spPr>
           <a:xfrm>
-            <a:off x="6921500" y="3098800"/>
-            <a:ext cx="4826000" cy="1549400"/>
+            <a:off x="5842000" y="3098800"/>
+            <a:ext cx="4699000" cy="1549400"/>
           </a:xfrm>
           <a:prstGeom prst="rect">
             <a:avLst/>
@@ -13520,7 +13520,7 @@
         </p:nvSpPr>
         <p:spPr>
           <a:xfrm>
-            <a:off x="6921500" y="3098800"/>
+            <a:off x="5842000" y="3098800"/>
             <a:ext cx="127000" cy="1549400"/>
           </a:xfrm>
           <a:prstGeom prst="rect">
@@ -13564,8 +13564,8 @@
         </p:nvSpPr>
         <p:spPr>
           <a:xfrm>
-            <a:off x="7264400" y="3251200"/>
-            <a:ext cx="4318000" cy="381000"/>
+            <a:off x="6184900" y="3251200"/>
+            <a:ext cx="4254500" cy="381000"/>
           </a:xfrm>
           <a:prstGeom prst="rect">
             <a:avLst/>
@@ -13604,8 +13604,8 @@
         </p:nvSpPr>
         <p:spPr>
           <a:xfrm>
-            <a:off x="7264400" y="3683000"/>
-            <a:ext cx="4381500" cy="914400"/>
+            <a:off x="6184900" y="3683000"/>
+            <a:ext cx="4254500" cy="914400"/>
           </a:xfrm>
           <a:prstGeom prst="rect">
             <a:avLst/>
@@ -13678,8 +13678,8 @@
         </p:nvSpPr>
         <p:spPr>
           <a:xfrm>
-            <a:off x="6921500" y="4800600"/>
-            <a:ext cx="4826000" cy="1549400"/>
+            <a:off x="5842000" y="4800600"/>
+            <a:ext cx="4699000" cy="1549400"/>
           </a:xfrm>
           <a:prstGeom prst="rect">
             <a:avLst/>
@@ -13729,7 +13729,7 @@
         </p:nvSpPr>
         <p:spPr>
           <a:xfrm>
-            <a:off x="6921500" y="4800600"/>
+            <a:off x="5842000" y="4800600"/>
             <a:ext cx="127000" cy="1549400"/>
           </a:xfrm>
           <a:prstGeom prst="rect">
@@ -13773,8 +13773,8 @@
         </p:nvSpPr>
         <p:spPr>
           <a:xfrm>
-            <a:off x="7264400" y="4953000"/>
-            <a:ext cx="4318000" cy="381000"/>
+            <a:off x="6184900" y="4953000"/>
+            <a:ext cx="4254500" cy="381000"/>
           </a:xfrm>
           <a:prstGeom prst="rect">
             <a:avLst/>
@@ -13813,8 +13813,8 @@
         </p:nvSpPr>
         <p:spPr>
           <a:xfrm>
-            <a:off x="7264400" y="5384800"/>
-            <a:ext cx="4381500" cy="914400"/>
+            <a:off x="6184900" y="5384800"/>
+            <a:ext cx="4254500" cy="914400"/>
           </a:xfrm>
           <a:prstGeom prst="rect">
             <a:avLst/>
@@ -17996,63 +17996,7 @@
       </p:sp>
       <p:sp>
         <p:nvSpPr>
-          <p:cNvPr id="6" name="Rectangle 5"/>
-          <p:cNvSpPr/>
-          <p:nvPr/>
-        </p:nvSpPr>
-        <p:spPr>
-          <a:xfrm>
-            <a:off x="863600" y="1930400"/>
-            <a:ext cx="711200" cy="711200"/>
-          </a:xfrm>
-          <a:prstGeom prst="rect">
-            <a:avLst/>
-          </a:prstGeom>
-          <a:noFill/>
-          <a:ln>
-            <a:noFill/>
-          </a:ln>
-          <a:effectLst/>
-        </p:spPr>
-        <p:style>
-          <a:lnRef idx="1">
-            <a:schemeClr val="accent1"/>
-          </a:lnRef>
-          <a:fillRef idx="3">
-            <a:schemeClr val="accent1"/>
-          </a:fillRef>
-          <a:effectRef idx="2">
-            <a:schemeClr val="accent1"/>
-          </a:effectRef>
-          <a:fontRef idx="minor">
-            <a:schemeClr val="lt1"/>
-          </a:fontRef>
-        </p:style>
-        <p:txBody>
-          <a:bodyPr rtlCol="0" anchor="ctr" wrap="square" lIns="101600" rIns="101600" tIns="50800" bIns="50800"/>
-          <a:lstStyle/>
-          <a:p>
-            <a:pPr algn="ctr">
-              <a:lnSpc>
-                <a:spcPct val="110000"/>
-              </a:lnSpc>
-            </a:pPr>
-            <a:r>
-              <a:rPr sz="2600" b="0">
-                <a:solidFill>
-                  <a:srgbClr val="1A3C8B"/>
-                </a:solidFill>
-                <a:latin typeface="微软雅黑"/>
-                <a:ea typeface="微软雅黑"/>
-              </a:rPr>
-              <a:t>■</a:t>
-            </a:r>
-          </a:p>
-        </p:txBody>
-      </p:sp>
-      <p:sp>
-        <p:nvSpPr>
-          <p:cNvPr id="7" name="TextBox 6"/>
+          <p:cNvPr id="6" name="TextBox 5"/>
           <p:cNvSpPr txBox="1"/>
           <p:nvPr/>
         </p:nvSpPr>
@@ -18092,7 +18036,7 @@
       </p:sp>
       <p:sp>
         <p:nvSpPr>
-          <p:cNvPr id="8" name="TextBox 7"/>
+          <p:cNvPr id="7" name="TextBox 6"/>
           <p:cNvSpPr txBox="1"/>
           <p:nvPr/>
         </p:nvSpPr>
@@ -18132,7 +18076,7 @@
       </p:sp>
       <p:sp>
         <p:nvSpPr>
-          <p:cNvPr id="9" name="Rectangle 8"/>
+          <p:cNvPr id="8" name="Rectangle 7"/>
           <p:cNvSpPr/>
           <p:nvPr/>
         </p:nvSpPr>
@@ -18183,7 +18127,7 @@
       </p:sp>
       <p:sp>
         <p:nvSpPr>
-          <p:cNvPr id="10" name="Rectangle 9"/>
+          <p:cNvPr id="9" name="Rectangle 8"/>
           <p:cNvSpPr/>
           <p:nvPr/>
         </p:nvSpPr>
@@ -18227,63 +18171,7 @@
       </p:sp>
       <p:sp>
         <p:nvSpPr>
-          <p:cNvPr id="11" name="Rectangle 10"/>
-          <p:cNvSpPr/>
-          <p:nvPr/>
-        </p:nvSpPr>
-        <p:spPr>
-          <a:xfrm>
-            <a:off x="7023100" y="1930400"/>
-            <a:ext cx="711200" cy="711200"/>
-          </a:xfrm>
-          <a:prstGeom prst="rect">
-            <a:avLst/>
-          </a:prstGeom>
-          <a:noFill/>
-          <a:ln>
-            <a:noFill/>
-          </a:ln>
-          <a:effectLst/>
-        </p:spPr>
-        <p:style>
-          <a:lnRef idx="1">
-            <a:schemeClr val="accent1"/>
-          </a:lnRef>
-          <a:fillRef idx="3">
-            <a:schemeClr val="accent1"/>
-          </a:fillRef>
-          <a:effectRef idx="2">
-            <a:schemeClr val="accent1"/>
-          </a:effectRef>
-          <a:fontRef idx="minor">
-            <a:schemeClr val="lt1"/>
-          </a:fontRef>
-        </p:style>
-        <p:txBody>
-          <a:bodyPr rtlCol="0" anchor="ctr" wrap="square" lIns="101600" rIns="101600" tIns="50800" bIns="50800"/>
-          <a:lstStyle/>
-          <a:p>
-            <a:pPr algn="ctr">
-              <a:lnSpc>
-                <a:spcPct val="110000"/>
-              </a:lnSpc>
-            </a:pPr>
-            <a:r>
-              <a:rPr sz="2600" b="0">
-                <a:solidFill>
-                  <a:srgbClr val="E67733"/>
-                </a:solidFill>
-                <a:latin typeface="微软雅黑"/>
-                <a:ea typeface="微软雅黑"/>
-              </a:rPr>
-              <a:t>■</a:t>
-            </a:r>
-          </a:p>
-        </p:txBody>
-      </p:sp>
-      <p:sp>
-        <p:nvSpPr>
-          <p:cNvPr id="12" name="TextBox 11"/>
+          <p:cNvPr id="10" name="TextBox 9"/>
           <p:cNvSpPr txBox="1"/>
           <p:nvPr/>
         </p:nvSpPr>
@@ -18323,7 +18211,7 @@
       </p:sp>
       <p:sp>
         <p:nvSpPr>
-          <p:cNvPr id="13" name="TextBox 12"/>
+          <p:cNvPr id="11" name="TextBox 10"/>
           <p:cNvSpPr txBox="1"/>
           <p:nvPr/>
         </p:nvSpPr>
@@ -18363,7 +18251,7 @@
       </p:sp>
       <p:sp>
         <p:nvSpPr>
-          <p:cNvPr id="14" name="Rectangle 13"/>
+          <p:cNvPr id="12" name="Rectangle 11"/>
           <p:cNvSpPr/>
           <p:nvPr/>
         </p:nvSpPr>
@@ -18414,7 +18302,7 @@
       </p:sp>
       <p:sp>
         <p:nvSpPr>
-          <p:cNvPr id="15" name="Rectangle 14"/>
+          <p:cNvPr id="13" name="Rectangle 12"/>
           <p:cNvSpPr/>
           <p:nvPr/>
         </p:nvSpPr>
@@ -18458,63 +18346,7 @@
       </p:sp>
       <p:sp>
         <p:nvSpPr>
-          <p:cNvPr id="16" name="Rectangle 15"/>
-          <p:cNvSpPr/>
-          <p:nvPr/>
-        </p:nvSpPr>
-        <p:spPr>
-          <a:xfrm>
-            <a:off x="863600" y="4470400"/>
-            <a:ext cx="711200" cy="711200"/>
-          </a:xfrm>
-          <a:prstGeom prst="rect">
-            <a:avLst/>
-          </a:prstGeom>
-          <a:noFill/>
-          <a:ln>
-            <a:noFill/>
-          </a:ln>
-          <a:effectLst/>
-        </p:spPr>
-        <p:style>
-          <a:lnRef idx="1">
-            <a:schemeClr val="accent1"/>
-          </a:lnRef>
-          <a:fillRef idx="3">
-            <a:schemeClr val="accent1"/>
-          </a:fillRef>
-          <a:effectRef idx="2">
-            <a:schemeClr val="accent1"/>
-          </a:effectRef>
-          <a:fontRef idx="minor">
-            <a:schemeClr val="lt1"/>
-          </a:fontRef>
-        </p:style>
-        <p:txBody>
-          <a:bodyPr rtlCol="0" anchor="ctr" wrap="square" lIns="101600" rIns="101600" tIns="50800" bIns="50800"/>
-          <a:lstStyle/>
-          <a:p>
-            <a:pPr algn="ctr">
-              <a:lnSpc>
-                <a:spcPct val="110000"/>
-              </a:lnSpc>
-            </a:pPr>
-            <a:r>
-              <a:rPr sz="2600" b="0">
-                <a:solidFill>
-                  <a:srgbClr val="C8504B"/>
-                </a:solidFill>
-                <a:latin typeface="微软雅黑"/>
-                <a:ea typeface="微软雅黑"/>
-              </a:rPr>
-              <a:t>■</a:t>
-            </a:r>
-          </a:p>
-        </p:txBody>
-      </p:sp>
-      <p:sp>
-        <p:nvSpPr>
-          <p:cNvPr id="17" name="TextBox 16"/>
+          <p:cNvPr id="14" name="TextBox 13"/>
           <p:cNvSpPr txBox="1"/>
           <p:nvPr/>
         </p:nvSpPr>
@@ -18554,7 +18386,7 @@
       </p:sp>
       <p:sp>
         <p:nvSpPr>
-          <p:cNvPr id="18" name="TextBox 17"/>
+          <p:cNvPr id="15" name="TextBox 14"/>
           <p:cNvSpPr txBox="1"/>
           <p:nvPr/>
         </p:nvSpPr>
@@ -18594,7 +18426,7 @@
       </p:sp>
       <p:sp>
         <p:nvSpPr>
-          <p:cNvPr id="19" name="Rectangle 18"/>
+          <p:cNvPr id="16" name="Rectangle 15"/>
           <p:cNvSpPr/>
           <p:nvPr/>
         </p:nvSpPr>
@@ -18645,7 +18477,7 @@
       </p:sp>
       <p:sp>
         <p:nvSpPr>
-          <p:cNvPr id="20" name="Rectangle 19"/>
+          <p:cNvPr id="17" name="Rectangle 16"/>
           <p:cNvSpPr/>
           <p:nvPr/>
         </p:nvSpPr>
@@ -18689,63 +18521,7 @@
       </p:sp>
       <p:sp>
         <p:nvSpPr>
-          <p:cNvPr id="21" name="Rectangle 20"/>
-          <p:cNvSpPr/>
-          <p:nvPr/>
-        </p:nvSpPr>
-        <p:spPr>
-          <a:xfrm>
-            <a:off x="7023100" y="4470400"/>
-            <a:ext cx="711200" cy="711200"/>
-          </a:xfrm>
-          <a:prstGeom prst="rect">
-            <a:avLst/>
-          </a:prstGeom>
-          <a:noFill/>
-          <a:ln>
-            <a:noFill/>
-          </a:ln>
-          <a:effectLst/>
-        </p:spPr>
-        <p:style>
-          <a:lnRef idx="1">
-            <a:schemeClr val="accent1"/>
-          </a:lnRef>
-          <a:fillRef idx="3">
-            <a:schemeClr val="accent1"/>
-          </a:fillRef>
-          <a:effectRef idx="2">
-            <a:schemeClr val="accent1"/>
-          </a:effectRef>
-          <a:fontRef idx="minor">
-            <a:schemeClr val="lt1"/>
-          </a:fontRef>
-        </p:style>
-        <p:txBody>
-          <a:bodyPr rtlCol="0" anchor="ctr" wrap="square" lIns="101600" rIns="101600" tIns="50800" bIns="50800"/>
-          <a:lstStyle/>
-          <a:p>
-            <a:pPr algn="ctr">
-              <a:lnSpc>
-                <a:spcPct val="110000"/>
-              </a:lnSpc>
-            </a:pPr>
-            <a:r>
-              <a:rPr sz="2600" b="0">
-                <a:solidFill>
-                  <a:srgbClr val="188050"/>
-                </a:solidFill>
-                <a:latin typeface="微软雅黑"/>
-                <a:ea typeface="微软雅黑"/>
-              </a:rPr>
-              <a:t>■</a:t>
-            </a:r>
-          </a:p>
-        </p:txBody>
-      </p:sp>
-      <p:sp>
-        <p:nvSpPr>
-          <p:cNvPr id="22" name="TextBox 21"/>
+          <p:cNvPr id="18" name="TextBox 17"/>
           <p:cNvSpPr txBox="1"/>
           <p:nvPr/>
         </p:nvSpPr>
@@ -18785,7 +18561,7 @@
       </p:sp>
       <p:sp>
         <p:nvSpPr>
-          <p:cNvPr id="23" name="TextBox 22"/>
+          <p:cNvPr id="19" name="TextBox 18"/>
           <p:cNvSpPr txBox="1"/>
           <p:nvPr/>
         </p:nvSpPr>
@@ -18825,7 +18601,7 @@
       </p:sp>
       <p:sp>
         <p:nvSpPr>
-          <p:cNvPr id="24" name="TextBox 23"/>
+          <p:cNvPr id="20" name="TextBox 19"/>
           <p:cNvSpPr txBox="1"/>
           <p:nvPr/>
         </p:nvSpPr>
@@ -20581,8 +20357,8 @@
         </p:blipFill>
         <p:spPr>
           <a:xfrm>
-            <a:off x="762000" y="2921000"/>
-            <a:ext cx="7112000" cy="4003220"/>
+            <a:off x="635000" y="2946400"/>
+            <a:ext cx="6032500" cy="3395588"/>
           </a:xfrm>
           <a:prstGeom prst="rect">
             <a:avLst/>
@@ -20597,8 +20373,8 @@
         </p:nvSpPr>
         <p:spPr>
           <a:xfrm>
-            <a:off x="8255000" y="2984500"/>
-            <a:ext cx="3429000" cy="3175000"/>
+            <a:off x="6921500" y="2984500"/>
+            <a:ext cx="4635500" cy="3175000"/>
           </a:xfrm>
           <a:prstGeom prst="rect">
             <a:avLst/>
@@ -20641,8 +20417,8 @@
         </p:nvSpPr>
         <p:spPr>
           <a:xfrm>
-            <a:off x="8255000" y="2984500"/>
-            <a:ext cx="3429000" cy="558800"/>
+            <a:off x="6921500" y="2984500"/>
+            <a:ext cx="4635500" cy="558800"/>
           </a:xfrm>
           <a:prstGeom prst="rect">
             <a:avLst/>
@@ -20685,8 +20461,8 @@
         </p:nvSpPr>
         <p:spPr>
           <a:xfrm>
-            <a:off x="8255000" y="3111500"/>
-            <a:ext cx="3429000" cy="381000"/>
+            <a:off x="6921500" y="3111500"/>
+            <a:ext cx="4635500" cy="381000"/>
           </a:xfrm>
           <a:prstGeom prst="rect">
             <a:avLst/>
@@ -20725,8 +20501,8 @@
         </p:nvSpPr>
         <p:spPr>
           <a:xfrm>
-            <a:off x="8483600" y="3708400"/>
-            <a:ext cx="2997200" cy="2286000"/>
+            <a:off x="7213600" y="3708400"/>
+            <a:ext cx="4064000" cy="2286000"/>
           </a:xfrm>
           <a:prstGeom prst="rect">
             <a:avLst/>

</xml_diff>